<commit_message>
docs: repository link in deck and Devpost text; no local user paths in docs
Co-Authored-By: Claude Opus 5.5 <noreply@anthropic.com>
</commit_message>
<xml_diff>
--- a/docs/ESP32-Assistant.pptx
+++ b/docs/ESP32-Assistant.pptx
@@ -116,27 +116,27 @@
   <p:extLst>
     <p:ext uri="{521415D9-36F7-43E2-AB2F-B90AF26B5E84}">
       <p14:sectionLst xmlns:p14="http://schemas.microsoft.com/office/powerpoint/2010/main">
-        <p14:section name="Why" id="{6b9c4061-0c08-c370-b84f-f1ad0cba107e}">
+        <p14:section name="Why" id="{a44d3b9e-de10-9bf9-322e-1311d13ad9da}">
           <p14:sldIdLst>
             <p14:sldId id="256"/>
             <p14:sldId id="257"/>
           </p14:sldIdLst>
         </p14:section>
-        <p14:section name="What" id="{4ac28447-f7e9-6636-eab4-a56e9f73d554}">
+        <p14:section name="What" id="{b97aed8a-fd92-f9ca-f9fa-7973bf659ab1}">
           <p14:sldIdLst>
             <p14:sldId id="258"/>
             <p14:sldId id="259"/>
             <p14:sldId id="260"/>
           </p14:sldIdLst>
         </p14:section>
-        <p14:section name="How" id="{91981f5d-f909-6135-ce10-aa87cb7f9ad6}">
+        <p14:section name="How" id="{e81943c0-5632-e59e-35ab-9204468a12c9}">
           <p14:sldIdLst>
             <p14:sldId id="261"/>
             <p14:sldId id="262"/>
             <p14:sldId id="263"/>
           </p14:sldIdLst>
         </p14:section>
-        <p14:section name="Next" id="{53c71525-aefe-7c0a-0796-e7d4f9e583bb}">
+        <p14:section name="Next" id="{55ffebec-9587-fa9b-1c11-f95cace38b23}">
           <p14:sldIdLst>
             <p14:sldId id="264"/>
             <p14:sldId id="265"/>
@@ -2278,7 +2278,7 @@
                   <a:schemeClr val="accent5"/>
                 </a:solidFill>
               </a:rPr>
-              <a:t>Open source (MIT)  ·  github.com/[your-account]/esp32s3-bringup</a:t>
+              <a:t>Open source (MIT)  ·  github.com/johnnyqiuyun/esp32-assistant</a:t>
             </a:r>
             <a:endParaRPr lang="en-US" sz="1200" dirty="0"/>
           </a:p>

</xml_diff>